<commit_message>
Accuracy, security hygiene, and documentation refresh (2026-07-07)
- Fix "in-account inference" → "PrivateLink" wording across .env.example, requirements, IaC, and deck scripts
- Redact AWS account ID/IAM user from verification docs; remove placeholder security email
- Remove stale root-level overview/one-pager files (superseded by decks/)
- Add capability maturity matrix and architecture diagrams to README
- Update test counts to 120 across all status docs
- Add clean-account acceptance evidence and .gitignore entries

All 120 tests pass.

Co-Authored-By: Claude Opus 4.6 (1M context) <noreply@anthropic.com>
</commit_message>
<xml_diff>
--- a/decks/EDU-01-Student-Family-Concierge.pptx
+++ b/decks/EDU-01-Student-Family-Concierge.pptx
@@ -7714,28 +7714,28 @@
         <a:sysClr val="window" lastClr="FFFFFF"/>
       </a:lt1>
       <a:dk2>
-        <a:srgbClr val="44546A"/>
+        <a:srgbClr val="232F3E"/>
       </a:dk2>
       <a:lt2>
         <a:srgbClr val="E7E6E6"/>
       </a:lt2>
       <a:accent1>
-        <a:srgbClr val="4472C4"/>
+        <a:srgbClr val="FF9900"/>
       </a:accent1>
       <a:accent2>
-        <a:srgbClr val="ED7D31"/>
+        <a:srgbClr val="232F3E"/>
       </a:accent2>
       <a:accent3>
-        <a:srgbClr val="A5A5A5"/>
+        <a:srgbClr val="01A88D"/>
       </a:accent3>
       <a:accent4>
-        <a:srgbClr val="FFC000"/>
+        <a:srgbClr val="8C4FFF"/>
       </a:accent4>
       <a:accent5>
-        <a:srgbClr val="5B9BD5"/>
+        <a:srgbClr val="DD344C"/>
       </a:accent5>
       <a:accent6>
-        <a:srgbClr val="70AD47"/>
+        <a:srgbClr val="ED7100"/>
       </a:accent6>
       <a:hlink>
         <a:srgbClr val="0563C1"/>
@@ -7746,7 +7746,7 @@
     </a:clrScheme>
     <a:fontScheme name="Office">
       <a:majorFont>
-        <a:latin typeface="Calibri Light" panose="020F0302020204030204"/>
+        <a:latin typeface="Amazon Ember" panose="020F0302020204030204"/>
         <a:ea typeface=""/>
         <a:cs typeface=""/>
         <a:font script="Jpan" typeface="游ゴシック Light"/>
@@ -7798,7 +7798,7 @@
         <a:font script="Tfng" typeface="Ebrima"/>
       </a:majorFont>
       <a:minorFont>
-        <a:latin typeface="Calibri" panose="020F0502020204030204"/>
+        <a:latin typeface="Amazon Ember" panose="020F0502020204030204"/>
         <a:ea typeface=""/>
         <a:cs typeface=""/>
         <a:font script="Jpan" typeface="游ゴシック"/>

</xml_diff>

<commit_message>
Add auditor/GRC assurance cover sheet and refresh decks
- Add assurance/README.md as a curated index for security/privacy reviewers, organized under standard assurance headings (threat model, control mappings, deployment evidence, shared responsibility, etc.)
- Add README callout directing auditors to the assurance packet
- Refresh deck content across all 10 .pptx files

Co-Authored-By: Claude Opus 4.6 (1M context) <noreply@anthropic.com>
</commit_message>
<xml_diff>
--- a/decks/EDU-01-Student-Family-Concierge.pptx
+++ b/decks/EDU-01-Student-Family-Concierge.pptx
@@ -11,6 +11,7 @@
     <p:sldId id="259" r:id="rId5"/>
     <p:sldId id="260" r:id="rId6"/>
     <p:sldId id="261" r:id="rId7"/>
+    <p:sldId id="262" r:id="rId13"/>
   </p:sldIdLst>
   <p:notesMasterIdLst>
     <p:notesMasterId r:id="rId8"/>
@@ -1538,6 +1539,40 @@
           </a:p>
         </p:txBody>
       </p:sp>
+      <p:sp>
+        <p:nvSpPr>
+          <p:cNvPr id="8" name="TextBox 7"/>
+          <p:cNvSpPr txBox="1"/>
+          <p:nvPr/>
+        </p:nvSpPr>
+        <p:spPr>
+          <a:xfrm>
+            <a:off x="365760" y="6291072"/>
+            <a:ext cx="11460480" cy="457200"/>
+          </a:xfrm>
+          <a:prstGeom prst="rect">
+            <a:avLst/>
+          </a:prstGeom>
+          <a:noFill/>
+        </p:spPr>
+        <p:txBody>
+          <a:bodyPr wrap="square" tIns="0" bIns="0">
+            <a:spAutoFit/>
+          </a:bodyPr>
+          <a:lstStyle/>
+          <a:p>
+            <a:pPr algn="l"/>
+            <a:r>
+              <a:rPr sz="800" i="1">
+                <a:solidFill>
+                  <a:srgbClr val="879296"/>
+                </a:solidFill>
+              </a:rPr>
+              <a:t>Reference accelerator — not an AWS service, not AWS-supported software, not a compliance certification, and not production-ready for regulated data without customer-specific engineering, testing, authorization, and operational ownership.</a:t>
+            </a:r>
+          </a:p>
+        </p:txBody>
+      </p:sp>
     </p:spTree>
   </p:cSld>
   <p:clrMapOvr>
@@ -7692,6 +7727,198 @@
               <a:t>the agent isn't the product — the governed platform that makes it FERPA/ADA-defensible and deployable on AWS is.</a:t>
             </a:r>
             <a:endParaRPr lang="en-US" sz="1400" dirty="0"/>
+          </a:p>
+        </p:txBody>
+      </p:sp>
+    </p:spTree>
+  </p:cSld>
+  <p:clrMapOvr>
+    <a:masterClrMapping/>
+  </p:clrMapOvr>
+</p:sld>
+</file>
+
+<file path=ppt/slides/slide7.xml><?xml version="1.0" encoding="utf-8"?>
+<p:sld xmlns:a="http://schemas.openxmlformats.org/drawingml/2006/main" xmlns:p="http://schemas.openxmlformats.org/presentationml/2006/main" xmlns:r="http://schemas.openxmlformats.org/officeDocument/2006/relationships">
+  <p:cSld>
+    <p:spTree>
+      <p:nvGrpSpPr>
+        <p:cNvPr id="1" name=""/>
+        <p:cNvGrpSpPr/>
+        <p:nvPr/>
+      </p:nvGrpSpPr>
+      <p:grpSpPr/>
+      <p:sp>
+        <p:nvSpPr>
+          <p:cNvPr id="2" name="Rectangle 1"/>
+          <p:cNvSpPr/>
+          <p:nvPr/>
+        </p:nvSpPr>
+        <p:spPr>
+          <a:xfrm>
+            <a:off x="0" y="0"/>
+            <a:ext cx="12192000" cy="6858000"/>
+          </a:xfrm>
+          <a:prstGeom prst="rect">
+            <a:avLst/>
+          </a:prstGeom>
+          <a:solidFill>
+            <a:srgbClr val="232F3E"/>
+          </a:solidFill>
+          <a:ln>
+            <a:noFill/>
+          </a:ln>
+          <a:effectLst/>
+        </p:spPr>
+        <p:style>
+          <a:lnRef idx="1">
+            <a:schemeClr val="accent1"/>
+          </a:lnRef>
+          <a:fillRef idx="3">
+            <a:schemeClr val="accent1"/>
+          </a:fillRef>
+          <a:effectRef idx="2">
+            <a:schemeClr val="accent1"/>
+          </a:effectRef>
+          <a:fontRef idx="minor">
+            <a:schemeClr val="lt1"/>
+          </a:fontRef>
+        </p:style>
+        <p:txBody>
+          <a:bodyPr rtlCol="0" anchor="ctr"/>
+          <a:lstStyle/>
+          <a:p>
+            <a:pPr algn="ctr"/>
+          </a:p>
+        </p:txBody>
+      </p:sp>
+      <p:sp>
+        <p:nvSpPr>
+          <p:cNvPr id="3" name="Rectangle 2"/>
+          <p:cNvSpPr/>
+          <p:nvPr/>
+        </p:nvSpPr>
+        <p:spPr>
+          <a:xfrm>
+            <a:off x="822960" y="1051560"/>
+            <a:ext cx="2011680" cy="82296"/>
+          </a:xfrm>
+          <a:prstGeom prst="rect">
+            <a:avLst/>
+          </a:prstGeom>
+          <a:solidFill>
+            <a:srgbClr val="FF9900"/>
+          </a:solidFill>
+          <a:ln>
+            <a:noFill/>
+          </a:ln>
+          <a:effectLst/>
+        </p:spPr>
+        <p:style>
+          <a:lnRef idx="1">
+            <a:schemeClr val="accent1"/>
+          </a:lnRef>
+          <a:fillRef idx="3">
+            <a:schemeClr val="accent1"/>
+          </a:fillRef>
+          <a:effectRef idx="2">
+            <a:schemeClr val="accent1"/>
+          </a:effectRef>
+          <a:fontRef idx="minor">
+            <a:schemeClr val="lt1"/>
+          </a:fontRef>
+        </p:style>
+        <p:txBody>
+          <a:bodyPr rtlCol="0" anchor="ctr"/>
+          <a:lstStyle/>
+          <a:p>
+            <a:pPr algn="ctr"/>
+          </a:p>
+        </p:txBody>
+      </p:sp>
+      <p:sp>
+        <p:nvSpPr>
+          <p:cNvPr id="4" name="TextBox 3"/>
+          <p:cNvSpPr txBox="1"/>
+          <p:nvPr/>
+        </p:nvSpPr>
+        <p:spPr>
+          <a:xfrm>
+            <a:off x="822960" y="1234440"/>
+            <a:ext cx="10546080" cy="914400"/>
+          </a:xfrm>
+          <a:prstGeom prst="rect">
+            <a:avLst/>
+          </a:prstGeom>
+          <a:noFill/>
+        </p:spPr>
+        <p:txBody>
+          <a:bodyPr wrap="square">
+            <a:spAutoFit/>
+          </a:bodyPr>
+          <a:lstStyle/>
+          <a:p>
+            <a:r>
+              <a:rPr sz="3400" b="1">
+                <a:solidFill>
+                  <a:srgbClr val="FFFFFF"/>
+                </a:solidFill>
+              </a:rPr>
+              <a:t>Disclaimer &amp; Shared Responsibility</a:t>
+            </a:r>
+          </a:p>
+        </p:txBody>
+      </p:sp>
+      <p:sp>
+        <p:nvSpPr>
+          <p:cNvPr id="5" name="TextBox 4"/>
+          <p:cNvSpPr txBox="1"/>
+          <p:nvPr/>
+        </p:nvSpPr>
+        <p:spPr>
+          <a:xfrm>
+            <a:off x="822960" y="2468880"/>
+            <a:ext cx="10546080" cy="3108960"/>
+          </a:xfrm>
+          <a:prstGeom prst="rect">
+            <a:avLst/>
+          </a:prstGeom>
+          <a:noFill/>
+        </p:spPr>
+        <p:txBody>
+          <a:bodyPr wrap="square">
+            <a:spAutoFit/>
+          </a:bodyPr>
+          <a:lstStyle/>
+          <a:p>
+            <a:pPr>
+              <a:spcAft>
+                <a:spcPts val="1200"/>
+              </a:spcAft>
+            </a:pPr>
+            <a:r>
+              <a:rPr sz="1600">
+                <a:solidFill>
+                  <a:srgbClr val="D5DBDB"/>
+                </a:solidFill>
+              </a:rPr>
+              <a:t>Reference accelerator — not an AWS service, not AWS-supported software, not a compliance certification, and not production-ready for regulated data without customer-specific engineering, testing, authorization, and operational ownership.</a:t>
+            </a:r>
+          </a:p>
+          <a:p>
+            <a:pPr>
+              <a:spcAft>
+                <a:spcPts val="1200"/>
+              </a:spcAft>
+            </a:pPr>
+            <a:r>
+              <a:rPr sz="1600">
+                <a:solidFill>
+                  <a:srgbClr val="D5DBDB"/>
+                </a:solidFill>
+              </a:rPr>
+              <a:t>Built on AWS; not affiliated with or endorsed by Amazon Web Services.</a:t>
+            </a:r>
           </a:p>
         </p:txBody>
       </p:sp>

</xml_diff>